<commit_message>
Hold M09 SAY pending Cloud re-check
Co-authored-by: shaseaver25 <shannon@tailoredu.org>
</commit_message>
<xml_diff>
--- a/teaching-pack/13-M09-false-precision/M09-instructor-reveal.pptx
+++ b/teaching-pack/13-M09-false-precision/M09-instructor-reveal.pptx
@@ -510,13 +510,19 @@
           <a:lstStyle/>
           <a:p>
             <a:r>
-              <a:t>OLI CANON SAY — revised M09 Cloud hard-review pass.</a:t>
+              <a:t>M09 SAY STATUS: HOLD — CLOUD RE-CHECK PASS REQUIRED.</a:t>
             </a:r>
           </a:p>
           <a:p/>
           <a:p>
             <a:r>
-              <a:t>REVEAL — Open only after students commit the precision audit, sampling-frame audit, and Note version 2.</a:t>
+              <a:t>PLACEHOLDER ONLY. Do not treat as canon dialogue.</a:t>
+            </a:r>
+          </a:p>
+          <a:p/>
+          <a:p>
+            <a:r>
+              <a:t>REVEAL TITLE HOOK — Open only after students commit the precision audit, sampling-frame audit, and Note version 2.</a:t>
             </a:r>
           </a:p>
         </p:txBody>
@@ -586,13 +592,19 @@
           <a:lstStyle/>
           <a:p>
             <a:r>
-              <a:t>OLI CANON SAY — revised M09 Cloud hard-review pass.</a:t>
+              <a:t>M09 SAY STATUS: HOLD — CLOUD RE-CHECK PASS REQUIRED.</a:t>
             </a:r>
           </a:p>
           <a:p/>
           <a:p>
             <a:r>
-              <a:t>REVEAL — Confirm that FOREMAN’s arithmetic produces 41,872,316 cycles. Its designed error is eight significant figures with no range when the fatigue scatter supports only two or three.</a:t>
+              <a:t>PLACEHOLDER ONLY. Do not treat as canon dialogue.</a:t>
+            </a:r>
+          </a:p>
+          <a:p/>
+          <a:p>
+            <a:r>
+              <a:t>REVEAL HOOK — Confirm 41,872,316 cycles and the unsupported single-cycle precision. Add no character dialogue.</a:t>
             </a:r>
           </a:p>
         </p:txBody>
@@ -662,13 +674,19 @@
           <a:lstStyle/>
           <a:p>
             <a:r>
-              <a:t>OLI CANON SAY — revised M09 Cloud hard-review pass.</a:t>
+              <a:t>M09 SAY STATUS: HOLD — CLOUD RE-CHECK PASS REQUIRED.</a:t>
             </a:r>
           </a:p>
           <a:p/>
           <a:p>
             <a:r>
-              <a:t>REVEAL — Show the small fatigue-test dataset and visible scatter. Do not turn the descriptive minimum and maximum into a formal interval.</a:t>
+              <a:t>PLACEHOLDER ONLY. Do not treat as canon dialogue.</a:t>
+            </a:r>
+          </a:p>
+          <a:p/>
+          <a:p>
+            <a:r>
+              <a:t>REVEAL HOOK — Show source resolution and fatigue spread; keep the observed span descriptive.</a:t>
             </a:r>
           </a:p>
         </p:txBody>
@@ -738,13 +756,19 @@
           <a:lstStyle/>
           <a:p>
             <a:r>
-              <a:t>OLI CANON SAY — revised M09 Cloud hard-review pass.</a:t>
+              <a:t>M09 SAY STATUS: HOLD — CLOUD RE-CHECK PASS REQUIRED.</a:t>
             </a:r>
           </a:p>
           <a:p/>
           <a:p>
             <a:r>
-              <a:t>REVEAL — A defensible response may keep a rounded planning estimate, but it must state the scatter, transfer limits, and need for qualified review.</a:t>
+              <a:t>PLACEHOLDER ONLY. Do not treat as canon dialogue.</a:t>
+            </a:r>
+          </a:p>
+          <a:p/>
+          <a:p>
+            <a:r>
+              <a:t>MODEL RESPONSE HOOK — Accept justified rounding alternatives and keep the estimate explicitly screening-level.</a:t>
             </a:r>
           </a:p>
         </p:txBody>
@@ -814,13 +838,19 @@
           <a:lstStyle/>
           <a:p>
             <a:r>
-              <a:t>OLI CANON SAY — revised M09 Cloud hard-review pass.</a:t>
+              <a:t>M09 SAY STATUS: HOLD — CLOUD RE-CHECK PASS REQUIRED.</a:t>
             </a:r>
           </a:p>
           <a:p/>
           <a:p>
             <a:r>
-              <a:t>REVEAL — Compare the class sample means. One fixed 200-value instructional population produced different n = 8 means: sampling variability.</a:t>
+              <a:t>PLACEHOLDER ONLY. Do not treat as canon dialogue.</a:t>
+            </a:r>
+          </a:p>
+          <a:p/>
+          <a:p>
+            <a:r>
+              <a:t>REVEAL HOOK — Compare the twelve sample means and name sampling variability.</a:t>
             </a:r>
           </a:p>
         </p:txBody>
@@ -890,13 +920,19 @@
           <a:lstStyle/>
           <a:p>
             <a:r>
-              <a:t>OLI CANON SAY — revised M09 Cloud hard-review pass.</a:t>
+              <a:t>M09 SAY STATUS: HOLD — CLOUD RE-CHECK PASS REQUIRED.</a:t>
             </a:r>
           </a:p>
           <a:p/>
           <a:p>
             <a:r>
-              <a:t>REVEAL — Every real Otter Bend core was drilled from the shoulder for easy access. That is a convenience frame and does not establish whole-deck representation. The 200-value demonstrator is not bridge truth.</a:t>
+              <a:t>PLACEHOLDER ONLY. Do not treat as canon dialogue.</a:t>
+            </a:r>
+          </a:p>
+          <a:p/>
+          <a:p>
+            <a:r>
+              <a:t>REVEAL HOOK — Confirm that every actual core is from a shoulder convenience frame; the simulated population is not bridge truth.</a:t>
             </a:r>
           </a:p>
         </p:txBody>
@@ -966,13 +1002,19 @@
           <a:lstStyle/>
           <a:p>
             <a:r>
-              <a:t>OLI CANON SAY — revised M09 Cloud hard-review pass.</a:t>
+              <a:t>M09 SAY STATUS: HOLD — CLOUD RE-CHECK PASS REQUIRED.</a:t>
             </a:r>
           </a:p>
           <a:p/>
           <a:p>
             <a:r>
-              <a:t>REVEAL — Randomness belongs to selection; precision belongs to evidence. Neither can be added after collection.</a:t>
+              <a:t>PLACEHOLDER ONLY. Do not treat as canon dialogue.</a:t>
+            </a:r>
+          </a:p>
+          <a:p/>
+          <a:p>
+            <a:r>
+              <a:t>REVEAL HOOK — Tie random sampling to selection and precision to evidence.</a:t>
             </a:r>
           </a:p>
         </p:txBody>
@@ -1042,13 +1084,19 @@
           <a:lstStyle/>
           <a:p>
             <a:r>
-              <a:t>OLI CANON SAY — revised M09 Cloud hard-review pass.</a:t>
+              <a:t>M09 SAY STATUS: HOLD — CLOUD RE-CHECK PASS REQUIRED.</a:t>
             </a:r>
           </a:p>
           <a:p/>
           <a:p>
             <a:r>
-              <a:t>NOTE — Compare claim/check/result records. The hand-in is Note version 2 only; do not require tomorrow’s methods.</a:t>
+              <a:t>PLACEHOLDER ONLY. Do not treat as canon dialogue.</a:t>
+            </a:r>
+          </a:p>
+          <a:p/>
+          <a:p>
+            <a:r>
+              <a:t>NOTE HOOK — Compare bounded Note v2 responses; assign no new homework number.</a:t>
             </a:r>
           </a:p>
         </p:txBody>
@@ -1118,13 +1166,19 @@
           <a:lstStyle/>
           <a:p>
             <a:r>
-              <a:t>OLI CANON SAY — revised M09 Cloud hard-review pass.</a:t>
+              <a:t>M09 SAY STATUS: HOLD — CLOUD RE-CHECK PASS REQUIRED.</a:t>
             </a:r>
           </a:p>
           <a:p/>
           <a:p>
             <a:r>
-              <a:t>CLOSE — Diane remains in BELIEVER mode and still wants one number. Hook only the plain question of whether the deck got worse; do not name confidence intervals, p-values, or later specifics.</a:t>
+              <a:t>PLACEHOLDER ONLY. Do not treat as canon dialogue.</a:t>
+            </a:r>
+          </a:p>
+          <a:p/>
+          <a:p>
+            <a:r>
+              <a:t>CLOSE HOOK — Paste only Cloud re-check PASS SAY. Diane remains BELIEVER; do not preview or name later methods.</a:t>
             </a:r>
           </a:p>
         </p:txBody>

</xml_diff>

<commit_message>
Fold Cloud-PASS M09 SAY
Co-authored-by: shaseaver25 <shannon@tailoredu.org>
</commit_message>
<xml_diff>
--- a/teaching-pack/13-M09-false-precision/M09-instructor-reveal.pptx
+++ b/teaching-pack/13-M09-false-precision/M09-instructor-reveal.pptx
@@ -510,19 +510,13 @@
           <a:lstStyle/>
           <a:p>
             <a:r>
-              <a:t>M09 SAY STATUS: HOLD — CLOUD RE-CHECK PASS REQUIRED.</a:t>
+              <a:t>OLI CANON SAY — revised M09 Cloud re-check PASS.</a:t>
             </a:r>
           </a:p>
           <a:p/>
           <a:p>
             <a:r>
-              <a:t>PLACEHOLDER ONLY. Do not treat as canon dialogue.</a:t>
-            </a:r>
-          </a:p>
-          <a:p/>
-          <a:p>
-            <a:r>
-              <a:t>REVEAL TITLE HOOK — Open only after students commit the precision audit, sampling-frame audit, and Note version 2.</a:t>
+              <a:t>REVEAL — Open only after students commit the precision audit, sampling-frame audit, and Note version 2.</a:t>
             </a:r>
           </a:p>
         </p:txBody>
@@ -592,19 +586,13 @@
           <a:lstStyle/>
           <a:p>
             <a:r>
-              <a:t>M09 SAY STATUS: HOLD — CLOUD RE-CHECK PASS REQUIRED.</a:t>
+              <a:t>OLI CANON SAY — revised M09 Cloud re-check PASS.</a:t>
             </a:r>
           </a:p>
           <a:p/>
           <a:p>
             <a:r>
-              <a:t>PLACEHOLDER ONLY. Do not treat as canon dialogue.</a:t>
-            </a:r>
-          </a:p>
-          <a:p/>
-          <a:p>
-            <a:r>
-              <a:t>REVEAL HOOK — Confirm 41,872,316 cycles and the unsupported single-cycle precision. Add no character dialogue.</a:t>
+              <a:t>REVEAL — Confirm that FOREMAN’s arithmetic produces 41,872,316 cycles. Its designed error is eight significant figures with no range when the fatigue scatter supports only two or three.</a:t>
             </a:r>
           </a:p>
         </p:txBody>
@@ -674,19 +662,13 @@
           <a:lstStyle/>
           <a:p>
             <a:r>
-              <a:t>M09 SAY STATUS: HOLD — CLOUD RE-CHECK PASS REQUIRED.</a:t>
+              <a:t>OLI CANON SAY — revised M09 Cloud re-check PASS.</a:t>
             </a:r>
           </a:p>
           <a:p/>
           <a:p>
             <a:r>
-              <a:t>PLACEHOLDER ONLY. Do not treat as canon dialogue.</a:t>
-            </a:r>
-          </a:p>
-          <a:p/>
-          <a:p>
-            <a:r>
-              <a:t>REVEAL HOOK — Show source resolution and fatigue spread; keep the observed span descriptive.</a:t>
+              <a:t>REVEAL — Show the small fatigue-test dataset and visible scatter. Keep the descriptive minimum and maximum separate from methods not yet taught.</a:t>
             </a:r>
           </a:p>
         </p:txBody>
@@ -756,19 +738,13 @@
           <a:lstStyle/>
           <a:p>
             <a:r>
-              <a:t>M09 SAY STATUS: HOLD — CLOUD RE-CHECK PASS REQUIRED.</a:t>
+              <a:t>OLI CANON SAY — revised M09 Cloud re-check PASS.</a:t>
             </a:r>
           </a:p>
           <a:p/>
           <a:p>
             <a:r>
-              <a:t>PLACEHOLDER ONLY. Do not treat as canon dialogue.</a:t>
-            </a:r>
-          </a:p>
-          <a:p/>
-          <a:p>
-            <a:r>
-              <a:t>MODEL RESPONSE HOOK — Accept justified rounding alternatives and keep the estimate explicitly screening-level.</a:t>
+              <a:t>REVEAL — A defensible response may keep a rounded planning estimate, but it must state the scatter, transfer limits, and need for qualified review.</a:t>
             </a:r>
           </a:p>
         </p:txBody>
@@ -838,19 +814,13 @@
           <a:lstStyle/>
           <a:p>
             <a:r>
-              <a:t>M09 SAY STATUS: HOLD — CLOUD RE-CHECK PASS REQUIRED.</a:t>
+              <a:t>OLI CANON SAY — revised M09 Cloud re-check PASS.</a:t>
             </a:r>
           </a:p>
           <a:p/>
           <a:p>
             <a:r>
-              <a:t>PLACEHOLDER ONLY. Do not treat as canon dialogue.</a:t>
-            </a:r>
-          </a:p>
-          <a:p/>
-          <a:p>
-            <a:r>
-              <a:t>REVEAL HOOK — Compare the twelve sample means and name sampling variability.</a:t>
+              <a:t>REVEAL — Compare the class sample means. One fixed 200-value instructional population produced different n = 8 means: sampling variability.</a:t>
             </a:r>
           </a:p>
         </p:txBody>
@@ -920,19 +890,13 @@
           <a:lstStyle/>
           <a:p>
             <a:r>
-              <a:t>M09 SAY STATUS: HOLD — CLOUD RE-CHECK PASS REQUIRED.</a:t>
+              <a:t>OLI CANON SAY — revised M09 Cloud re-check PASS.</a:t>
             </a:r>
           </a:p>
           <a:p/>
           <a:p>
             <a:r>
-              <a:t>PLACEHOLDER ONLY. Do not treat as canon dialogue.</a:t>
-            </a:r>
-          </a:p>
-          <a:p/>
-          <a:p>
-            <a:r>
-              <a:t>REVEAL HOOK — Confirm that every actual core is from a shoulder convenience frame; the simulated population is not bridge truth.</a:t>
+              <a:t>REVEAL — Every real Otter Bend core was drilled from the shoulder for easy access. That is a convenience frame and does not establish whole-deck representation. The 200-value demonstrator is not bridge truth.</a:t>
             </a:r>
           </a:p>
         </p:txBody>
@@ -1002,19 +966,13 @@
           <a:lstStyle/>
           <a:p>
             <a:r>
-              <a:t>M09 SAY STATUS: HOLD — CLOUD RE-CHECK PASS REQUIRED.</a:t>
+              <a:t>OLI CANON SAY — revised M09 Cloud re-check PASS.</a:t>
             </a:r>
           </a:p>
           <a:p/>
           <a:p>
             <a:r>
-              <a:t>PLACEHOLDER ONLY. Do not treat as canon dialogue.</a:t>
-            </a:r>
-          </a:p>
-          <a:p/>
-          <a:p>
-            <a:r>
-              <a:t>REVEAL HOOK — Tie random sampling to selection and precision to evidence.</a:t>
+              <a:t>REVEAL — Randomness belongs to selection; precision belongs to evidence. Neither can be added after collection.</a:t>
             </a:r>
           </a:p>
         </p:txBody>
@@ -1084,19 +1042,13 @@
           <a:lstStyle/>
           <a:p>
             <a:r>
-              <a:t>M09 SAY STATUS: HOLD — CLOUD RE-CHECK PASS REQUIRED.</a:t>
+              <a:t>OLI CANON SAY — revised M09 Cloud re-check PASS.</a:t>
             </a:r>
           </a:p>
           <a:p/>
           <a:p>
             <a:r>
-              <a:t>PLACEHOLDER ONLY. Do not treat as canon dialogue.</a:t>
-            </a:r>
-          </a:p>
-          <a:p/>
-          <a:p>
-            <a:r>
-              <a:t>NOTE HOOK — Compare bounded Note v2 responses; assign no new homework number.</a:t>
+              <a:t>NOTE — Compare claim/check/result records. The hand-in is Note version 2 only; do not require a later method.</a:t>
             </a:r>
           </a:p>
         </p:txBody>
@@ -1166,19 +1118,13 @@
           <a:lstStyle/>
           <a:p>
             <a:r>
-              <a:t>M09 SAY STATUS: HOLD — CLOUD RE-CHECK PASS REQUIRED.</a:t>
+              <a:t>OLI CANON SAY — revised M09 Cloud re-check PASS.</a:t>
             </a:r>
           </a:p>
           <a:p/>
           <a:p>
             <a:r>
-              <a:t>PLACEHOLDER ONLY. Do not treat as canon dialogue.</a:t>
-            </a:r>
-          </a:p>
-          <a:p/>
-          <a:p>
-            <a:r>
-              <a:t>CLOSE HOOK — Paste only Cloud re-check PASS SAY. Diane remains BELIEVER; do not preview or name later methods.</a:t>
+              <a:t>CLOSE — Diane remains in BELIEVER mode and still wants one number. Hook only the plain question of whether the deck got worse; do not preview or name a later statistical method.</a:t>
             </a:r>
           </a:p>
         </p:txBody>

</xml_diff>